<commit_message>
pdf and zip created
</commit_message>
<xml_diff>
--- a/CDSD_Concepteur_Developpeur_Sciences_Donnees/Presentations_certification/ppt_versions/Bloc4_CDSD_Loic_Valentini.pptx
+++ b/CDSD_Concepteur_Developpeur_Sciences_Donnees/Presentations_certification/ppt_versions/Bloc4_CDSD_Loic_Valentini.pptx
@@ -8468,7 +8468,14 @@
                 <a:latin typeface="Inter Medium" panose="020B0604020202020204" charset="0"/>
                 <a:ea typeface="Inter Medium" panose="020B0604020202020204" charset="0"/>
               </a:rPr>
-              <a:t> : Identifier l’architecture Deep Learning la plus performante pour détecter les SPAM</a:t>
+              <a:t> : </a:t>
+            </a:r>
+            <a:r>
+              <a:rPr lang="fr-FR" sz="1200" dirty="0">
+                <a:latin typeface="Inter Medium" panose="020B0604020202020204" charset="0"/>
+                <a:ea typeface="Inter Medium" panose="020B0604020202020204" charset="0"/>
+              </a:rPr>
+              <a:t>Identifier l’architecture Deep Learning la plus performante pour détecter les SPAM</a:t>
             </a:r>
             <a:br>
               <a:rPr lang="fr-FR" sz="1400" dirty="0">
@@ -8981,7 +8988,55 @@
         </p:nvSpPr>
         <p:spPr>
           <a:xfrm rot="21244006">
-            <a:off x="566302" y="3524015"/>
+            <a:off x="566299" y="3450519"/>
+            <a:ext cx="261199" cy="46747"/>
+          </a:xfrm>
+          <a:prstGeom prst="roundRect">
+            <a:avLst>
+              <a:gd name="adj" fmla="val 50000"/>
+            </a:avLst>
+          </a:prstGeom>
+          <a:solidFill>
+            <a:srgbClr val="C3FFFC"/>
+          </a:solidFill>
+          <a:ln>
+            <a:noFill/>
+          </a:ln>
+        </p:spPr>
+        <p:txBody>
+          <a:bodyPr spcFirstLastPara="1" wrap="square" lIns="91425" tIns="91425" rIns="91425" bIns="91425" anchor="ctr" anchorCtr="0">
+            <a:noAutofit/>
+          </a:bodyPr>
+          <a:lstStyle/>
+          <a:p>
+            <a:pPr marL="0" lvl="0" indent="0" algn="l" rtl="0">
+              <a:spcBef>
+                <a:spcPts val="0"/>
+              </a:spcBef>
+              <a:spcAft>
+                <a:spcPts val="0"/>
+              </a:spcAft>
+              <a:buNone/>
+            </a:pPr>
+            <a:endParaRPr/>
+          </a:p>
+        </p:txBody>
+      </p:sp>
+      <p:sp>
+        <p:nvSpPr>
+          <p:cNvPr id="2" name="Google Shape;72;p15">
+            <a:extLst>
+              <a:ext uri="{FF2B5EF4-FFF2-40B4-BE49-F238E27FC236}">
+                <a16:creationId xmlns:a16="http://schemas.microsoft.com/office/drawing/2014/main" id="{0D3E9531-E056-3BF5-C47E-A8AE01A4CB18}"/>
+              </a:ext>
+            </a:extLst>
+          </p:cNvPr>
+          <p:cNvSpPr/>
+          <p:nvPr/>
+        </p:nvSpPr>
+        <p:spPr>
+          <a:xfrm rot="21244006">
+            <a:off x="566299" y="2461551"/>
             <a:ext cx="261199" cy="46747"/>
           </a:xfrm>
           <a:prstGeom prst="roundRect">
@@ -9238,21 +9293,7 @@
                 <a:latin typeface="Inter Medium" panose="020B0604020202020204" charset="0"/>
                 <a:ea typeface="Inter Medium" panose="020B0604020202020204" charset="0"/>
               </a:rPr>
-              <a:t>Sur-échantillonnage des </a:t>
-            </a:r>
-            <a:r>
-              <a:rPr lang="fr-FR" sz="1400" dirty="0" err="1">
-                <a:latin typeface="Inter Medium" panose="020B0604020202020204" charset="0"/>
-                <a:ea typeface="Inter Medium" panose="020B0604020202020204" charset="0"/>
-              </a:rPr>
-              <a:t>SPAMs</a:t>
-            </a:r>
-            <a:r>
-              <a:rPr lang="fr-FR" sz="1400" dirty="0">
-                <a:latin typeface="Inter Medium" panose="020B0604020202020204" charset="0"/>
-                <a:ea typeface="Inter Medium" panose="020B0604020202020204" charset="0"/>
-              </a:rPr>
-              <a:t> par duplication (</a:t>
+              <a:t>Sur-échantillonnage des SPAM par duplication (</a:t>
             </a:r>
             <a:r>
               <a:rPr lang="fr-FR" sz="1400" dirty="0" err="1">
@@ -9266,7 +9307,7 @@
                 <a:latin typeface="Inter Medium" panose="020B0604020202020204" charset="0"/>
                 <a:ea typeface="Inter Medium" panose="020B0604020202020204" charset="0"/>
               </a:rPr>
-              <a:t>) pour compenser le déséquilibre initia</a:t>
+              <a:t>) pour compenser le déséquilibre initial</a:t>
             </a:r>
             <a:br>
               <a:rPr lang="fr-FR" sz="1050" dirty="0"/>
@@ -20111,8 +20152,8 @@
         </p:blipFill>
         <p:spPr>
           <a:xfrm>
-            <a:off x="6859658" y="2702355"/>
-            <a:ext cx="1612800" cy="1441022"/>
+            <a:off x="6796800" y="2646192"/>
+            <a:ext cx="1675658" cy="1497185"/>
           </a:xfrm>
           <a:prstGeom prst="rect">
             <a:avLst/>

</xml_diff>

<commit_message>
project at&t correction - oversampling
</commit_message>
<xml_diff>
--- a/CDSD_Concepteur_Developpeur_Sciences_Donnees/Presentations_certification/ppt_versions/Bloc4_CDSD_Loic_Valentini.pptx
+++ b/CDSD_Concepteur_Developpeur_Sciences_Donnees/Presentations_certification/ppt_versions/Bloc4_CDSD_Loic_Valentini.pptx
@@ -10117,14 +10117,14 @@
           <p:nvPr>
             <p:extLst>
               <p:ext uri="{D42A27DB-BD31-4B8C-83A1-F6EECF244321}">
-                <p14:modId xmlns:p14="http://schemas.microsoft.com/office/powerpoint/2010/main" val="3483041342"/>
+                <p14:modId xmlns:p14="http://schemas.microsoft.com/office/powerpoint/2010/main" val="1924841223"/>
               </p:ext>
             </p:extLst>
           </p:nvPr>
         </p:nvGraphicFramePr>
         <p:xfrm>
           <a:off x="511200" y="956582"/>
-          <a:ext cx="8200799" cy="3584638"/>
+          <a:ext cx="8200799" cy="3715768"/>
         </p:xfrm>
         <a:graphic>
           <a:graphicData uri="http://schemas.openxmlformats.org/drawingml/2006/table">
@@ -10919,7 +10919,7 @@
                           <a:latin typeface="Inter Medium" panose="020B0604020202020204" charset="0"/>
                           <a:ea typeface="Inter Medium" panose="020B0604020202020204" charset="0"/>
                         </a:rPr>
-                        <a:t>0.997</a:t>
+                        <a:t>0.98</a:t>
                       </a:r>
                     </a:p>
                   </a:txBody>
@@ -11202,7 +11202,7 @@
                           <a:latin typeface="Inter Medium" panose="020B0604020202020204" charset="0"/>
                           <a:ea typeface="Inter Medium" panose="020B0604020202020204" charset="0"/>
                         </a:rPr>
-                        <a:t>0.997</a:t>
+                        <a:t>0.98</a:t>
                       </a:r>
                     </a:p>
                   </a:txBody>
@@ -11480,7 +11480,7 @@
                           <a:latin typeface="Inter Medium" panose="020B0604020202020204" charset="0"/>
                           <a:ea typeface="Inter Medium" panose="020B0604020202020204" charset="0"/>
                         </a:rPr>
-                        <a:t>0.997</a:t>
+                        <a:t>0.87</a:t>
                       </a:r>
                     </a:p>
                   </a:txBody>
@@ -13060,7 +13060,21 @@
                           <a:latin typeface="Inter Medium" panose="020B0604020202020204" charset="0"/>
                           <a:ea typeface="Inter Medium" panose="020B0604020202020204" charset="0"/>
                         </a:rPr>
-                        <a:t>Poids du modèle (.h5)</a:t>
+                        <a:t>Poids du modèle (.</a:t>
+                      </a:r>
+                      <a:r>
+                        <a:rPr lang="fr-FR" sz="1200" b="1" dirty="0" err="1">
+                          <a:latin typeface="Inter Medium" panose="020B0604020202020204" charset="0"/>
+                          <a:ea typeface="Inter Medium" panose="020B0604020202020204" charset="0"/>
+                        </a:rPr>
+                        <a:t>keras</a:t>
+                      </a:r>
+                      <a:r>
+                        <a:rPr lang="fr-FR" sz="1200" b="1" dirty="0">
+                          <a:latin typeface="Inter Medium" panose="020B0604020202020204" charset="0"/>
+                          <a:ea typeface="Inter Medium" panose="020B0604020202020204" charset="0"/>
+                        </a:rPr>
+                        <a:t>)</a:t>
                       </a:r>
                     </a:p>
                   </a:txBody>
@@ -13207,10 +13221,10 @@
       </p:pic>
       <p:pic>
         <p:nvPicPr>
-          <p:cNvPr id="8" name="Image 7">
+          <p:cNvPr id="5" name="Image 4">
             <a:extLst>
               <a:ext uri="{FF2B5EF4-FFF2-40B4-BE49-F238E27FC236}">
-                <a16:creationId xmlns:a16="http://schemas.microsoft.com/office/drawing/2014/main" id="{8B8E247D-7867-7162-9959-3CA97A910DAA}"/>
+                <a16:creationId xmlns:a16="http://schemas.microsoft.com/office/drawing/2014/main" id="{885BA485-69A3-600C-9953-77F4825B3C35}"/>
               </a:ext>
             </a:extLst>
           </p:cNvPr>
@@ -13227,8 +13241,8 @@
         </p:blipFill>
         <p:spPr>
           <a:xfrm>
-            <a:off x="6833458" y="2648184"/>
-            <a:ext cx="1694587" cy="1514098"/>
+            <a:off x="6879770" y="2671285"/>
+            <a:ext cx="1679575" cy="1515633"/>
           </a:xfrm>
           <a:prstGeom prst="rect">
             <a:avLst/>
@@ -13573,14 +13587,14 @@
           <p:nvPr>
             <p:extLst>
               <p:ext uri="{D42A27DB-BD31-4B8C-83A1-F6EECF244321}">
-                <p14:modId xmlns:p14="http://schemas.microsoft.com/office/powerpoint/2010/main" val="887774144"/>
+                <p14:modId xmlns:p14="http://schemas.microsoft.com/office/powerpoint/2010/main" val="68274916"/>
               </p:ext>
             </p:extLst>
           </p:nvPr>
         </p:nvGraphicFramePr>
         <p:xfrm>
           <a:off x="511200" y="956582"/>
-          <a:ext cx="8200799" cy="3584638"/>
+          <a:ext cx="8200799" cy="3715768"/>
         </p:xfrm>
         <a:graphic>
           <a:graphicData uri="http://schemas.openxmlformats.org/drawingml/2006/table">
@@ -14375,7 +14389,7 @@
                           <a:latin typeface="Inter Medium" panose="020B0604020202020204" charset="0"/>
                           <a:ea typeface="Inter Medium" panose="020B0604020202020204" charset="0"/>
                         </a:rPr>
-                        <a:t>0.996</a:t>
+                        <a:t>0.99</a:t>
                       </a:r>
                     </a:p>
                   </a:txBody>
@@ -14661,7 +14675,7 @@
                           <a:latin typeface="Inter Medium" panose="020B0604020202020204" charset="0"/>
                           <a:ea typeface="Inter Medium" panose="020B0604020202020204" charset="0"/>
                         </a:rPr>
-                        <a:t>0.998</a:t>
+                        <a:t>0.99</a:t>
                       </a:r>
                     </a:p>
                   </a:txBody>
@@ -14944,7 +14958,7 @@
                           <a:latin typeface="Inter Medium" panose="020B0604020202020204" charset="0"/>
                           <a:ea typeface="Inter Medium" panose="020B0604020202020204" charset="0"/>
                         </a:rPr>
-                        <a:t>0.994</a:t>
+                        <a:t>0.91</a:t>
                       </a:r>
                     </a:p>
                   </a:txBody>
@@ -16528,7 +16542,21 @@
                           <a:latin typeface="Inter Medium" panose="020B0604020202020204" charset="0"/>
                           <a:ea typeface="Inter Medium" panose="020B0604020202020204" charset="0"/>
                         </a:rPr>
-                        <a:t>Poids du modèle (.h5)</a:t>
+                        <a:t>Poids du modèle (.</a:t>
+                      </a:r>
+                      <a:r>
+                        <a:rPr lang="fr-FR" sz="1200" b="1" dirty="0" err="1">
+                          <a:latin typeface="Inter Medium" panose="020B0604020202020204" charset="0"/>
+                          <a:ea typeface="Inter Medium" panose="020B0604020202020204" charset="0"/>
+                        </a:rPr>
+                        <a:t>keras</a:t>
+                      </a:r>
+                      <a:r>
+                        <a:rPr lang="fr-FR" sz="1200" b="1" dirty="0">
+                          <a:latin typeface="Inter Medium" panose="020B0604020202020204" charset="0"/>
+                          <a:ea typeface="Inter Medium" panose="020B0604020202020204" charset="0"/>
+                        </a:rPr>
+                        <a:t>)</a:t>
                       </a:r>
                     </a:p>
                   </a:txBody>
@@ -16675,10 +16703,10 @@
       </p:pic>
       <p:pic>
         <p:nvPicPr>
-          <p:cNvPr id="14" name="Image 13">
+          <p:cNvPr id="5" name="Image 4">
             <a:extLst>
               <a:ext uri="{FF2B5EF4-FFF2-40B4-BE49-F238E27FC236}">
-                <a16:creationId xmlns:a16="http://schemas.microsoft.com/office/drawing/2014/main" id="{9B676EB9-C718-BB00-FAD5-B83F5BDB293F}"/>
+                <a16:creationId xmlns:a16="http://schemas.microsoft.com/office/drawing/2014/main" id="{26D6949A-9781-3650-F987-3E749D6D9500}"/>
               </a:ext>
             </a:extLst>
           </p:cNvPr>
@@ -16695,8 +16723,8 @@
         </p:blipFill>
         <p:spPr>
           <a:xfrm>
-            <a:off x="6775200" y="2595622"/>
-            <a:ext cx="1780987" cy="1591296"/>
+            <a:off x="6850742" y="2625444"/>
+            <a:ext cx="1730375" cy="1561474"/>
           </a:xfrm>
           <a:prstGeom prst="rect">
             <a:avLst/>
@@ -17041,7 +17069,7 @@
           <p:nvPr>
             <p:extLst>
               <p:ext uri="{D42A27DB-BD31-4B8C-83A1-F6EECF244321}">
-                <p14:modId xmlns:p14="http://schemas.microsoft.com/office/powerpoint/2010/main" val="3421780398"/>
+                <p14:modId xmlns:p14="http://schemas.microsoft.com/office/powerpoint/2010/main" val="32839489"/>
               </p:ext>
             </p:extLst>
           </p:nvPr>
@@ -17843,7 +17871,7 @@
                           <a:latin typeface="Inter Medium" panose="020B0604020202020204" charset="0"/>
                           <a:ea typeface="Inter Medium" panose="020B0604020202020204" charset="0"/>
                         </a:rPr>
-                        <a:t>0.999</a:t>
+                        <a:t>0.99</a:t>
                       </a:r>
                     </a:p>
                   </a:txBody>
@@ -18157,7 +18185,7 @@
                           <a:latin typeface="Inter Medium" panose="020B0604020202020204" charset="0"/>
                           <a:ea typeface="Inter Medium" panose="020B0604020202020204" charset="0"/>
                         </a:rPr>
-                        <a:t>0.998</a:t>
+                        <a:t>0.97</a:t>
                       </a:r>
                     </a:p>
                   </a:txBody>
@@ -18435,7 +18463,7 @@
                           <a:latin typeface="Inter Medium" panose="020B0604020202020204" charset="0"/>
                           <a:ea typeface="Inter Medium" panose="020B0604020202020204" charset="0"/>
                         </a:rPr>
-                        <a:t>1.000</a:t>
+                        <a:t>0.99</a:t>
                       </a:r>
                     </a:p>
                   </a:txBody>
@@ -20132,10 +20160,10 @@
       </p:graphicFrame>
       <p:pic>
         <p:nvPicPr>
-          <p:cNvPr id="9" name="Image 8">
+          <p:cNvPr id="5" name="Image 4">
             <a:extLst>
               <a:ext uri="{FF2B5EF4-FFF2-40B4-BE49-F238E27FC236}">
-                <a16:creationId xmlns:a16="http://schemas.microsoft.com/office/drawing/2014/main" id="{BB9126D7-445F-43C3-0CCD-08FB7AF89E52}"/>
+                <a16:creationId xmlns:a16="http://schemas.microsoft.com/office/drawing/2014/main" id="{AF038EA9-3053-6DA0-F42C-0F1FD57266B4}"/>
               </a:ext>
             </a:extLst>
           </p:cNvPr>
@@ -20152,8 +20180,8 @@
         </p:blipFill>
         <p:spPr>
           <a:xfrm>
-            <a:off x="6796800" y="2646192"/>
-            <a:ext cx="1675658" cy="1497185"/>
+            <a:off x="6801547" y="2638541"/>
+            <a:ext cx="1715861" cy="1548377"/>
           </a:xfrm>
           <a:prstGeom prst="rect">
             <a:avLst/>
@@ -20317,7 +20345,7 @@
                 <a:latin typeface="Inter Medium" panose="020B0604020202020204" charset="0"/>
                 <a:ea typeface="Inter Medium" panose="020B0604020202020204" charset="0"/>
               </a:rPr>
-              <a:t>3 modèles très performants, détectant plus de 99,5% des spams</a:t>
+              <a:t>3 modèles à performance élevée mais néanmoins variable (Bert étant significativement meilleur), détectant une grande majorité de spams</a:t>
             </a:r>
             <a:br>
               <a:rPr lang="fr-FR" sz="1400" dirty="0">
@@ -20355,7 +20383,7 @@
                 <a:latin typeface="Inter Medium" panose="020B0604020202020204" charset="0"/>
                 <a:ea typeface="Inter Medium" panose="020B0604020202020204" charset="0"/>
               </a:rPr>
-              <a:t>Le choix du modèle dépend du contexte opérationnel :</a:t>
+              <a:t>Le choix du modèle dépendra du contexte opérationnel :</a:t>
             </a:r>
             <a:br>
               <a:rPr lang="fr-FR" sz="1400" dirty="0">
@@ -20429,6 +20457,33 @@
                 <a:ea typeface="Inter Medium" panose="020B0604020202020204" charset="0"/>
               </a:rPr>
               <a:t>Critère : légèreté</a:t>
+            </a:r>
+            <a:br>
+              <a:rPr lang="fr-FR" sz="1400" u="sng" dirty="0">
+                <a:latin typeface="Inter Medium" panose="020B0604020202020204" charset="0"/>
+                <a:ea typeface="Inter Medium" panose="020B0604020202020204" charset="0"/>
+              </a:rPr>
+            </a:br>
+            <a:r>
+              <a:rPr lang="fr-FR" sz="1400" dirty="0">
+                <a:latin typeface="Inter Medium" panose="020B0604020202020204" charset="0"/>
+                <a:ea typeface="Inter Medium" panose="020B0604020202020204" charset="0"/>
+              </a:rPr>
+              <a:t>	-&gt; Performance optimale ? </a:t>
+            </a:r>
+            <a:r>
+              <a:rPr lang="fr-FR" sz="1400" u="sng" dirty="0">
+                <a:latin typeface="Inter Medium" panose="020B0604020202020204" charset="0"/>
+                <a:ea typeface="Inter Medium" panose="020B0604020202020204" charset="0"/>
+              </a:rPr>
+              <a:t>Critère : </a:t>
+            </a:r>
+            <a:r>
+              <a:rPr lang="fr-FR" sz="1400" u="sng" dirty="0" err="1">
+                <a:latin typeface="Inter Medium" panose="020B0604020202020204" charset="0"/>
+                <a:ea typeface="Inter Medium" panose="020B0604020202020204" charset="0"/>
+              </a:rPr>
+              <a:t>metrics</a:t>
             </a:r>
             <a:br>
               <a:rPr lang="fr-FR" sz="1400" dirty="0">
@@ -20591,7 +20646,7 @@
         </p:nvSpPr>
         <p:spPr>
           <a:xfrm rot="21244006">
-            <a:off x="566298" y="1811195"/>
+            <a:off x="566299" y="2050681"/>
             <a:ext cx="261199" cy="46747"/>
           </a:xfrm>
           <a:prstGeom prst="roundRect">
@@ -20729,7 +20784,7 @@
         </p:nvSpPr>
         <p:spPr>
           <a:xfrm rot="21244006">
-            <a:off x="566299" y="2244464"/>
+            <a:off x="566298" y="2454921"/>
             <a:ext cx="261199" cy="46747"/>
           </a:xfrm>
           <a:prstGeom prst="roundRect">

</xml_diff>